<commit_message>
Update deck with latest slide tweaks
Co-Authored-By: Claude Opus 4.8 (1M context) <noreply@anthropic.com>
</commit_message>
<xml_diff>
--- a/kubecon-india-2026-kubeflow-cilium.pptx
+++ b/kubecon-india-2026-kubeflow-cilium.pptx
@@ -5,7 +5,7 @@
     <p:sldMasterId id="2147483648" r:id="rId1"/>
   </p:sldMasterIdLst>
   <p:notesMasterIdLst>
-    <p:notesMasterId r:id="rId20"/>
+    <p:notesMasterId r:id="rId23"/>
   </p:notesMasterIdLst>
   <p:sldIdLst>
     <p:sldId id="256" r:id="rId2"/>
@@ -19,14 +19,16 @@
     <p:sldId id="268" r:id="rId10"/>
     <p:sldId id="269" r:id="rId11"/>
     <p:sldId id="276" r:id="rId12"/>
-    <p:sldId id="270" r:id="rId13"/>
-    <p:sldId id="271" r:id="rId14"/>
-    <p:sldId id="272" r:id="rId15"/>
-    <p:sldId id="273" r:id="rId16"/>
-    <p:sldId id="277" r:id="rId17"/>
-    <p:sldId id="279" r:id="rId26"/>
-    <p:sldId id="274" r:id="rId18"/>
-    <p:sldId id="278" r:id="rId19"/>
+    <p:sldId id="281" r:id="rId13"/>
+    <p:sldId id="270" r:id="rId14"/>
+    <p:sldId id="271" r:id="rId15"/>
+    <p:sldId id="272" r:id="rId16"/>
+    <p:sldId id="280" r:id="rId17"/>
+    <p:sldId id="273" r:id="rId18"/>
+    <p:sldId id="277" r:id="rId19"/>
+    <p:sldId id="279" r:id="rId20"/>
+    <p:sldId id="274" r:id="rId21"/>
+    <p:sldId id="278" r:id="rId22"/>
   </p:sldIdLst>
   <p:sldSz cx="9144000" cy="5143500" type="screen16x9"/>
   <p:notesSz cx="6858000" cy="9144000"/>
@@ -275,7 +277,7 @@
       </p15:sldGuideLst>
     </p:ext>
     <p:ext uri="GoogleSlidesCustomDataVersion2">
-      <go:slidesCustomData xmlns:go="http://customooxmlschemas.google.com/" xmlns:ahyp="http://schemas.microsoft.com/office/drawing/2018/hyperlinkcolor" xmlns:p15="http://schemas.microsoft.com/office/powerpoint/2012/main" xmlns:p14="http://schemas.microsoft.com/office/powerpoint/2010/main" xmlns:com="http://schemas.openxmlformats.org/drawingml/2006/compatibility" xmlns:pvml="urn:schemas-microsoft-com:office:powerpoint" xmlns:v="urn:schemas-microsoft-com:vml" xmlns:o="urn:schemas-microsoft-com:office:office" xmlns:dgm="http://schemas.openxmlformats.org/drawingml/2006/diagram" xmlns:c="http://schemas.openxmlformats.org/drawingml/2006/chart" xmlns:mv="urn:schemas-microsoft-com:mac:vml" xmlns:mc="http://schemas.openxmlformats.org/markup-compatibility/2006" xmlns="" r:id="rId21" roundtripDataSignature="AMtx7mjt4YpfaHaeGNLmNMXSHSDobWMlBA=="/>
+      <go:slidesCustomData xmlns:go="http://customooxmlschemas.google.com/" xmlns:ahyp="http://schemas.microsoft.com/office/drawing/2018/hyperlinkcolor" xmlns:p15="http://schemas.microsoft.com/office/powerpoint/2012/main" xmlns:p14="http://schemas.microsoft.com/office/powerpoint/2010/main" xmlns:com="http://schemas.openxmlformats.org/drawingml/2006/compatibility" xmlns:pvml="urn:schemas-microsoft-com:office:powerpoint" xmlns:v="urn:schemas-microsoft-com:vml" xmlns:o="urn:schemas-microsoft-com:office:office" xmlns:dgm="http://schemas.openxmlformats.org/drawingml/2006/diagram" xmlns:c="http://schemas.openxmlformats.org/drawingml/2006/chart" xmlns:mv="urn:schemas-microsoft-com:mac:vml" xmlns:mc="http://schemas.openxmlformats.org/markup-compatibility/2006" xmlns="" r:id="rId24" roundtripDataSignature="AMtx7mjt4YpfaHaeGNLmNMXSHSDobWMlBA=="/>
     </p:ext>
   </p:extLst>
 </p:presentation>
@@ -1049,8 +1051,8 @@
         </p:nvSpPr>
         <p:spPr>
           <a:xfrm>
-            <a:off x="381300" y="685800"/>
-            <a:ext cx="6096075" cy="3429000"/>
+            <a:off x="381000" y="685800"/>
+            <a:ext cx="6096000" cy="3429000"/>
           </a:xfrm>
           <a:custGeom>
             <a:avLst/>
@@ -8269,7 +8271,7 @@
         </p:nvSpPr>
         <p:spPr>
           <a:xfrm>
-            <a:off x="207848" y="2889504"/>
+            <a:off x="239653" y="2711394"/>
             <a:ext cx="8010201" cy="1100000"/>
           </a:xfrm>
           <a:prstGeom prst="rect">
@@ -8368,7 +8370,7 @@
         </p:nvSpPr>
         <p:spPr>
           <a:xfrm>
-            <a:off x="311700" y="445025"/>
+            <a:off x="311700" y="100925"/>
             <a:ext cx="8520600" cy="572700"/>
           </a:xfrm>
           <a:prstGeom prst="rect">
@@ -8402,7 +8404,7 @@
               <a:rPr lang="en-US" sz="2800" b="1" dirty="0"/>
               <a:t>The Smoking Gun: GPUWorkersCantReachCoordinator</a:t>
             </a:r>
-            <a:endParaRPr/>
+            <a:endParaRPr dirty="0"/>
           </a:p>
         </p:txBody>
       </p:sp>
@@ -8418,7 +8420,7 @@
         </p:nvSpPr>
         <p:spPr>
           <a:xfrm>
-            <a:off x="311700" y="1152475"/>
+            <a:off x="311700" y="800783"/>
             <a:ext cx="8520600" cy="3317400"/>
           </a:xfrm>
           <a:prstGeom prst="rect">
@@ -8604,7 +8606,7 @@
               <a:rPr lang="en-US" sz="1800" b="0" dirty="0"/>
               <a:t>3. Root cause: no topology awareness in workload spec</a:t>
             </a:r>
-            <a:endParaRPr/>
+            <a:endParaRPr dirty="0"/>
           </a:p>
         </p:txBody>
       </p:sp>
@@ -9237,38 +9239,8 @@
         </p:blipFill>
         <p:spPr>
           <a:xfrm>
-            <a:off x="228600" y="190184"/>
-            <a:ext cx="8597348" cy="2193316"/>
-          </a:xfrm>
-          <a:prstGeom prst="rect">
-            <a:avLst/>
-          </a:prstGeom>
-        </p:spPr>
-      </p:pic>
-      <p:pic>
-        <p:nvPicPr>
-          <p:cNvPr id="5" name="CoordinatorZoneChart">
-            <a:extLst>
-              <a:ext uri="{FF2B5EF4-FFF2-40B4-BE49-F238E27FC236}">
-                <a16:creationId xmlns:a16="http://schemas.microsoft.com/office/drawing/2014/main" id="{66509244-BAB5-5F13-3511-9F8F1C73E535}"/>
-              </a:ext>
-            </a:extLst>
-          </p:cNvPr>
-          <p:cNvPicPr>
-            <a:picLocks noChangeAspect="1"/>
-          </p:cNvPicPr>
-          <p:nvPr/>
-        </p:nvPicPr>
-        <p:blipFill>
-          <a:blip r:embed="rId3"/>
-          <a:stretch>
-            <a:fillRect/>
-          </a:stretch>
-        </p:blipFill>
-        <p:spPr>
-          <a:xfrm>
-            <a:off x="228600" y="2457850"/>
-            <a:ext cx="8686800" cy="2100000"/>
+            <a:off x="71498" y="55901"/>
+            <a:ext cx="9001004" cy="4420182"/>
           </a:xfrm>
           <a:prstGeom prst="rect">
             <a:avLst/>
@@ -9289,6 +9261,66 @@
 </file>
 
 <file path=ppt/slides/slide12.xml><?xml version="1.0" encoding="utf-8"?>
+<p:sld xmlns:a="http://schemas.openxmlformats.org/drawingml/2006/main" xmlns:r="http://schemas.openxmlformats.org/officeDocument/2006/relationships" xmlns:p="http://schemas.openxmlformats.org/presentationml/2006/main">
+  <p:cSld>
+    <p:spTree>
+      <p:nvGrpSpPr>
+        <p:cNvPr id="1" name=""/>
+        <p:cNvGrpSpPr/>
+        <p:nvPr/>
+      </p:nvGrpSpPr>
+      <p:grpSpPr>
+        <a:xfrm>
+          <a:off x="0" y="0"/>
+          <a:ext cx="0" cy="0"/>
+          <a:chOff x="0" y="0"/>
+          <a:chExt cx="0" cy="0"/>
+        </a:xfrm>
+      </p:grpSpPr>
+      <p:pic>
+        <p:nvPicPr>
+          <p:cNvPr id="4" name="CoordinatorZoneChart">
+            <a:extLst>
+              <a:ext uri="{FF2B5EF4-FFF2-40B4-BE49-F238E27FC236}">
+                <a16:creationId xmlns:a16="http://schemas.microsoft.com/office/drawing/2014/main" id="{9E9D2726-B348-41D0-D22A-0418AD374D38}"/>
+              </a:ext>
+            </a:extLst>
+          </p:cNvPr>
+          <p:cNvPicPr>
+            <a:picLocks noChangeAspect="1"/>
+          </p:cNvPicPr>
+          <p:nvPr/>
+        </p:nvPicPr>
+        <p:blipFill>
+          <a:blip r:embed="rId2"/>
+          <a:stretch>
+            <a:fillRect/>
+          </a:stretch>
+        </p:blipFill>
+        <p:spPr>
+          <a:xfrm>
+            <a:off x="51372" y="115099"/>
+            <a:ext cx="9041255" cy="4175547"/>
+          </a:xfrm>
+          <a:prstGeom prst="rect">
+            <a:avLst/>
+          </a:prstGeom>
+        </p:spPr>
+      </p:pic>
+    </p:spTree>
+    <p:extLst>
+      <p:ext uri="{BB962C8B-B14F-4D97-AF65-F5344CB8AC3E}">
+        <p14:creationId xmlns:p14="http://schemas.microsoft.com/office/powerpoint/2010/main" val="3794030169"/>
+      </p:ext>
+    </p:extLst>
+  </p:cSld>
+  <p:clrMapOvr>
+    <a:masterClrMapping/>
+  </p:clrMapOvr>
+</p:sld>
+</file>
+
+<file path=ppt/slides/slide13.xml><?xml version="1.0" encoding="utf-8"?>
 <p:sld xmlns:a="http://schemas.openxmlformats.org/drawingml/2006/main" xmlns:r="http://schemas.openxmlformats.org/officeDocument/2006/relationships" xmlns:p="http://schemas.openxmlformats.org/presentationml/2006/main">
   <p:cSld>
     <p:spTree>
@@ -9400,7 +9432,7 @@
 </p:sld>
 </file>
 
-<file path=ppt/slides/slide13.xml><?xml version="1.0" encoding="utf-8"?>
+<file path=ppt/slides/slide14.xml><?xml version="1.0" encoding="utf-8"?>
 <p:sld xmlns:a="http://schemas.openxmlformats.org/drawingml/2006/main" xmlns:r="http://schemas.openxmlformats.org/officeDocument/2006/relationships" xmlns:p="http://schemas.openxmlformats.org/presentationml/2006/main">
   <p:cSld>
     <p:spTree>
@@ -9479,8 +9511,8 @@
         </p:nvSpPr>
         <p:spPr>
           <a:xfrm>
-            <a:off x="311700" y="1152475"/>
-            <a:ext cx="8520600" cy="3317400"/>
+            <a:off x="356461" y="1152475"/>
+            <a:ext cx="8520600" cy="3227694"/>
           </a:xfrm>
           <a:prstGeom prst="rect">
             <a:avLst/>
@@ -9646,7 +9678,7 @@
               <a:rPr lang="en-US" sz="1800" b="1" dirty="0"/>
               <a:t>Result: coordinator → zone-a | workers → zone-a | Cilium allows all traffic</a:t>
             </a:r>
-            <a:endParaRPr/>
+            <a:endParaRPr dirty="0"/>
           </a:p>
         </p:txBody>
       </p:sp>
@@ -10179,7 +10211,7 @@
 </p:sld>
 </file>
 
-<file path=ppt/slides/slide14.xml><?xml version="1.0" encoding="utf-8"?>
+<file path=ppt/slides/slide15.xml><?xml version="1.0" encoding="utf-8"?>
 <p:sld xmlns:a="http://schemas.openxmlformats.org/drawingml/2006/main" xmlns:r="http://schemas.openxmlformats.org/officeDocument/2006/relationships" xmlns:p="http://schemas.openxmlformats.org/presentationml/2006/main">
   <p:cSld>
     <p:spTree>
@@ -10208,7 +10240,7 @@
         </p:nvSpPr>
         <p:spPr>
           <a:xfrm>
-            <a:off x="311700" y="445025"/>
+            <a:off x="401222" y="1001338"/>
             <a:ext cx="8520600" cy="572700"/>
           </a:xfrm>
           <a:prstGeom prst="rect">
@@ -10299,13 +10331,44 @@
               <a:rPr lang="en-US" sz="1800" b="0" dirty="0"/>
               <a:t>Grafana: http://localhost:3000  |  Conflict score drops to 0</a:t>
             </a:r>
-            <a:endParaRPr/>
+            <a:endParaRPr dirty="0"/>
           </a:p>
         </p:txBody>
       </p:sp>
+    </p:spTree>
+  </p:cSld>
+  <p:clrMapOvr>
+    <a:masterClrMapping/>
+  </p:clrMapOvr>
+</p:sld>
+</file>
+
+<file path=ppt/slides/slide16.xml><?xml version="1.0" encoding="utf-8"?>
+<p:sld xmlns:a="http://schemas.openxmlformats.org/drawingml/2006/main" xmlns:r="http://schemas.openxmlformats.org/officeDocument/2006/relationships" xmlns:p="http://schemas.openxmlformats.org/presentationml/2006/main">
+  <p:cSld>
+    <p:spTree>
+      <p:nvGrpSpPr>
+        <p:cNvPr id="1" name=""/>
+        <p:cNvGrpSpPr/>
+        <p:nvPr/>
+      </p:nvGrpSpPr>
+      <p:grpSpPr>
+        <a:xfrm>
+          <a:off x="0" y="0"/>
+          <a:ext cx="0" cy="0"/>
+          <a:chOff x="0" y="0"/>
+          <a:chExt cx="0" cy="0"/>
+        </a:xfrm>
+      </p:grpSpPr>
       <p:pic>
         <p:nvPicPr>
-          <p:cNvPr id="211" name="GrafanaDashboardScreenshot"/>
+          <p:cNvPr id="3" name="GrafanaDashboardScreenshot">
+            <a:extLst>
+              <a:ext uri="{FF2B5EF4-FFF2-40B4-BE49-F238E27FC236}">
+                <a16:creationId xmlns:a16="http://schemas.microsoft.com/office/drawing/2014/main" id="{88719DD0-F67B-C408-C907-B226128109FE}"/>
+              </a:ext>
+            </a:extLst>
+          </p:cNvPr>
           <p:cNvPicPr>
             <a:picLocks noChangeAspect="1"/>
           </p:cNvPicPr>
@@ -10319,8 +10382,8 @@
         </p:blipFill>
         <p:spPr>
           <a:xfrm>
-            <a:off x="228600" y="2050000"/>
-            <a:ext cx="8686800" cy="2900000"/>
+            <a:off x="0" y="0"/>
+            <a:ext cx="8989179" cy="4578394"/>
           </a:xfrm>
           <a:prstGeom prst="rect">
             <a:avLst/>
@@ -10328,6 +10391,11 @@
         </p:spPr>
       </p:pic>
     </p:spTree>
+    <p:extLst>
+      <p:ext uri="{BB962C8B-B14F-4D97-AF65-F5344CB8AC3E}">
+        <p14:creationId xmlns:p14="http://schemas.microsoft.com/office/powerpoint/2010/main" val="3570846722"/>
+      </p:ext>
+    </p:extLst>
   </p:cSld>
   <p:clrMapOvr>
     <a:masterClrMapping/>
@@ -10335,7 +10403,7 @@
 </p:sld>
 </file>
 
-<file path=ppt/slides/slide15.xml><?xml version="1.0" encoding="utf-8"?>
+<file path=ppt/slides/slide17.xml><?xml version="1.0" encoding="utf-8"?>
 <p:sld xmlns:a="http://schemas.openxmlformats.org/drawingml/2006/main" xmlns:r="http://schemas.openxmlformats.org/officeDocument/2006/relationships" xmlns:p="http://schemas.openxmlformats.org/presentationml/2006/main">
   <p:cSld>
     <p:spTree>
@@ -11626,7 +11694,7 @@
 </p:sld>
 </file>
 
-<file path=ppt/slides/slide16.xml><?xml version="1.0" encoding="utf-8"?>
+<file path=ppt/slides/slide18.xml><?xml version="1.0" encoding="utf-8"?>
 <p:sld xmlns:a="http://schemas.openxmlformats.org/drawingml/2006/main" xmlns:r="http://schemas.openxmlformats.org/officeDocument/2006/relationships" xmlns:p="http://schemas.openxmlformats.org/presentationml/2006/main">
   <p:cSld>
     <p:spTree>
@@ -11665,8 +11733,8 @@
         </p:blipFill>
         <p:spPr>
           <a:xfrm>
-            <a:off x="109330" y="92702"/>
-            <a:ext cx="8686800" cy="4065829"/>
+            <a:off x="142113" y="143856"/>
+            <a:ext cx="8859774" cy="4146789"/>
           </a:xfrm>
           <a:prstGeom prst="rect">
             <a:avLst/>
@@ -11677,927 +11745,6 @@
     <p:extLst>
       <p:ext uri="{BB962C8B-B14F-4D97-AF65-F5344CB8AC3E}">
         <p14:creationId xmlns:p14="http://schemas.microsoft.com/office/powerpoint/2010/main" val="2933751399"/>
-      </p:ext>
-    </p:extLst>
-  </p:cSld>
-  <p:clrMapOvr>
-    <a:masterClrMapping/>
-  </p:clrMapOvr>
-</p:sld>
-</file>
-
-<file path=ppt/slides/slide17.xml><?xml version="1.0" encoding="utf-8"?>
-<p:sld xmlns:a="http://schemas.openxmlformats.org/drawingml/2006/main" xmlns:r="http://schemas.openxmlformats.org/officeDocument/2006/relationships" xmlns:p="http://schemas.openxmlformats.org/presentationml/2006/main">
-  <p:cSld>
-    <p:spTree>
-      <p:nvGrpSpPr>
-        <p:cNvPr id="1" name="Shape 88"/>
-        <p:cNvGrpSpPr/>
-        <p:nvPr/>
-      </p:nvGrpSpPr>
-      <p:grpSpPr>
-        <a:xfrm>
-          <a:off x="0" y="0"/>
-          <a:ext cx="0" cy="0"/>
-          <a:chOff x="0" y="0"/>
-          <a:chExt cx="0" cy="0"/>
-        </a:xfrm>
-      </p:grpSpPr>
-      <p:sp>
-        <p:nvSpPr>
-          <p:cNvPr id="89" name="Google Shape;89;p5"/>
-          <p:cNvSpPr txBox="1">
-            <a:spLocks noGrp="1"/>
-          </p:cNvSpPr>
-          <p:nvPr>
-            <p:ph type="title"/>
-          </p:nvPr>
-        </p:nvSpPr>
-        <p:spPr>
-          <a:xfrm>
-            <a:off x="311700" y="445025"/>
-            <a:ext cx="8520600" cy="572700"/>
-          </a:xfrm>
-          <a:prstGeom prst="rect">
-            <a:avLst/>
-          </a:prstGeom>
-          <a:noFill/>
-          <a:ln>
-            <a:noFill/>
-          </a:ln>
-        </p:spPr>
-        <p:txBody>
-          <a:bodyPr spcFirstLastPara="1" wrap="square" lIns="0" tIns="0" rIns="0" bIns="0" anchor="ctr" anchorCtr="0">
-            <a:normAutofit/>
-          </a:bodyPr>
-          <a:lstStyle/>
-          <a:p>
-            <a:pPr marL="0" lvl="0" indent="0" algn="l" rtl="0">
-              <a:lnSpc>
-                <a:spcPct val="100000"/>
-              </a:lnSpc>
-              <a:spcBef>
-                <a:spcPts val="0"/>
-              </a:spcBef>
-              <a:spcAft>
-                <a:spcPts val="0"/>
-              </a:spcAft>
-              <a:buSzPts val="2800"/>
-              <a:buNone/>
-            </a:pPr>
-            <a:r>
-              <a:rPr lang="en-US" sz="2800" b="1" dirty="0"/>
-              <a:t>Key Takeaways</a:t>
-            </a:r>
-            <a:endParaRPr/>
-          </a:p>
-        </p:txBody>
-      </p:sp>
-      <p:sp>
-        <p:nvSpPr>
-          <p:cNvPr id="90" name="Google Shape;90;p5"/>
-          <p:cNvSpPr txBox="1">
-            <a:spLocks noGrp="1"/>
-          </p:cNvSpPr>
-          <p:nvPr>
-            <p:ph type="body" idx="1"/>
-          </p:nvPr>
-        </p:nvSpPr>
-        <p:spPr>
-          <a:xfrm>
-            <a:off x="311700" y="1152475"/>
-            <a:ext cx="8520600" cy="3317400"/>
-          </a:xfrm>
-          <a:prstGeom prst="rect">
-            <a:avLst/>
-          </a:prstGeom>
-          <a:noFill/>
-          <a:ln>
-            <a:noFill/>
-          </a:ln>
-        </p:spPr>
-        <p:txBody>
-          <a:bodyPr spcFirstLastPara="1" wrap="square" lIns="0" tIns="0" rIns="0" bIns="0" anchor="t" anchorCtr="0">
-            <a:noAutofit/>
-          </a:bodyPr>
-          <a:lstStyle/>
-          <a:p>
-            <a:pPr marL="457200" lvl="0" indent="-228600" algn="l" rtl="0">
-              <a:lnSpc>
-                <a:spcPct val="115000"/>
-              </a:lnSpc>
-              <a:spcBef>
-                <a:spcPts val="0"/>
-              </a:spcBef>
-              <a:spcAft>
-                <a:spcPts val="0"/>
-              </a:spcAft>
-              <a:buSzPts val="1800"/>
-              <a:buNone/>
-            </a:pPr>
-            <a:r>
-              <a:rPr lang="en-US" sz="1900" b="1" dirty="0"/>
-              <a:t>1. Your CNI has opinions about topology — your scheduler doesn’t know</a:t>
-            </a:r>
-          </a:p>
-          <a:p>
-            <a:pPr marL="457200" lvl="0" indent="-228600" algn="l" rtl="0">
-              <a:lnSpc>
-                <a:spcPct val="115000"/>
-              </a:lnSpc>
-              <a:spcBef>
-                <a:spcPts val="100"/>
-              </a:spcBef>
-              <a:spcAft>
-                <a:spcPts val="0"/>
-              </a:spcAft>
-              <a:buSzPts val="1800"/>
-              <a:buNone/>
-            </a:pPr>
-            <a:r>
-              <a:rPr lang="en-US" sz="1600" b="0" dirty="0"/>
-              <a:t>Cilium topology-aware policies are silent to the Kubernetes scheduler</a:t>
-            </a:r>
-          </a:p>
-          <a:p>
-            <a:pPr marL="457200" lvl="0" indent="-228600" algn="l" rtl="0">
-              <a:lnSpc>
-                <a:spcPct val="115000"/>
-              </a:lnSpc>
-              <a:spcBef>
-                <a:spcPts val="400"/>
-              </a:spcBef>
-              <a:spcAft>
-                <a:spcPts val="0"/>
-              </a:spcAft>
-              <a:buSzPts val="1800"/>
-              <a:buNone/>
-            </a:pPr>
-            <a:r>
-              <a:rPr lang="en-US" sz="1900" b="1" dirty="0"/>
-              <a:t>2. Topology spread constraints = Kubernetes-native fix</a:t>
-            </a:r>
-          </a:p>
-          <a:p>
-            <a:pPr marL="457200" lvl="0" indent="-228600" algn="l" rtl="0">
-              <a:lnSpc>
-                <a:spcPct val="115000"/>
-              </a:lnSpc>
-              <a:spcBef>
-                <a:spcPts val="100"/>
-              </a:spcBef>
-              <a:spcAft>
-                <a:spcPts val="0"/>
-              </a:spcAft>
-              <a:buSzPts val="1800"/>
-              <a:buNone/>
-            </a:pPr>
-            <a:r>
-              <a:rPr lang="en-US" sz="1600" b="0" dirty="0"/>
-              <a:t>No Kubeflow patch, no Cilium change — 3 YAML stanzas in your workload spec</a:t>
-            </a:r>
-          </a:p>
-          <a:p>
-            <a:pPr marL="457200" lvl="0" indent="-228600" algn="l" rtl="0">
-              <a:lnSpc>
-                <a:spcPct val="115000"/>
-              </a:lnSpc>
-              <a:spcBef>
-                <a:spcPts val="400"/>
-              </a:spcBef>
-              <a:spcAft>
-                <a:spcPts val="0"/>
-              </a:spcAft>
-              <a:buSzPts val="1800"/>
-              <a:buNone/>
-            </a:pPr>
-            <a:r>
-              <a:rPr lang="en-US" sz="1900" b="1" dirty="0"/>
-              <a:t>3. Instrument before you need it: GPU utilization + pod zone metrics</a:t>
-            </a:r>
-          </a:p>
-          <a:p>
-            <a:pPr marL="457200" lvl="0" indent="-228600" algn="l" rtl="0">
-              <a:lnSpc>
-                <a:spcPct val="115000"/>
-              </a:lnSpc>
-              <a:spcBef>
-                <a:spcPts val="100"/>
-              </a:spcBef>
-              <a:spcAft>
-                <a:spcPts val="0"/>
-              </a:spcAft>
-              <a:buSzPts val="1800"/>
-              <a:buNone/>
-            </a:pPr>
-            <a:r>
-              <a:rPr lang="en-US" sz="1600" b="0" dirty="0"/>
-              <a:t>Prometheus + Grafana dashboards exposed this in seconds, not days</a:t>
-            </a:r>
-          </a:p>
-          <a:p>
-            <a:pPr marL="457200" lvl="0" indent="-228600" algn="l" rtl="0">
-              <a:lnSpc>
-                <a:spcPct val="115000"/>
-              </a:lnSpc>
-              <a:spcBef>
-                <a:spcPts val="400"/>
-              </a:spcBef>
-              <a:spcAft>
-                <a:spcPts val="0"/>
-              </a:spcAft>
-              <a:buSzPts val="1800"/>
-              <a:buNone/>
-            </a:pPr>
-            <a:r>
-              <a:rPr lang="en-US" sz="1900" b="1" dirty="0"/>
-              <a:t>4. Pattern applies beyond Kubeflow/Cilium</a:t>
-            </a:r>
-          </a:p>
-          <a:p>
-            <a:pPr marL="457200" lvl="0" indent="-228600" algn="l" rtl="0">
-              <a:lnSpc>
-                <a:spcPct val="115000"/>
-              </a:lnSpc>
-              <a:spcBef>
-                <a:spcPts val="100"/>
-              </a:spcBef>
-              <a:spcAft>
-                <a:spcPts val="0"/>
-              </a:spcAft>
-              <a:buSzPts val="1800"/>
-              <a:buNone/>
-            </a:pPr>
-            <a:r>
-              <a:rPr lang="en-US" sz="1600" b="0" dirty="0"/>
-              <a:t>Same root cause, 3 faces in prod: hard Cilium block, cross-zone NCCL latency, cross-AZ egress cost</a:t>
-            </a:r>
-          </a:p>
-        </p:txBody>
-      </p:sp>
-    </p:spTree>
-  </p:cSld>
-  <p:clrMapOvr>
-    <a:masterClrMapping/>
-  </p:clrMapOvr>
-  <p:timing>
-    <p:tnLst>
-      <p:par>
-        <p:cTn id="1" dur="indefinite" restart="never" nodeType="tmRoot">
-          <p:childTnLst>
-            <p:seq concurrent="1" nextAc="seek">
-              <p:cTn id="2" dur="indefinite" nodeType="mainSeq">
-                <p:childTnLst>
-                  <p:par>
-                    <p:cTn id="3" fill="hold">
-                      <p:stCondLst>
-                        <p:cond delay="indefinite"/>
-                      </p:stCondLst>
-                      <p:childTnLst>
-                        <p:par>
-                          <p:cTn id="4" fill="hold">
-                            <p:stCondLst>
-                              <p:cond delay="0"/>
-                            </p:stCondLst>
-                            <p:childTnLst>
-                              <p:par>
-                                <p:cTn id="5" presetID="10" presetClass="entr" presetSubtype="0" fill="hold" grpId="0" nodeType="clickEffect">
-                                  <p:stCondLst>
-                                    <p:cond delay="0"/>
-                                  </p:stCondLst>
-                                  <p:childTnLst>
-                                    <p:set>
-                                      <p:cBhvr>
-                                        <p:cTn id="6" dur="1" fill="hold">
-                                          <p:stCondLst>
-                                            <p:cond delay="0"/>
-                                          </p:stCondLst>
-                                        </p:cTn>
-                                        <p:tgtEl>
-                                          <p:spTgt spid="90">
-                                            <p:txEl>
-                                              <p:pRg st="0" end="0"/>
-                                            </p:txEl>
-                                          </p:spTgt>
-                                        </p:tgtEl>
-                                        <p:attrNameLst>
-                                          <p:attrName>style.visibility</p:attrName>
-                                        </p:attrNameLst>
-                                      </p:cBhvr>
-                                      <p:to>
-                                        <p:strVal val="visible"/>
-                                      </p:to>
-                                    </p:set>
-                                    <p:animEffect transition="in" filter="fade">
-                                      <p:cBhvr>
-                                        <p:cTn id="7" dur="500"/>
-                                        <p:tgtEl>
-                                          <p:spTgt spid="90">
-                                            <p:txEl>
-                                              <p:pRg st="0" end="0"/>
-                                            </p:txEl>
-                                          </p:spTgt>
-                                        </p:tgtEl>
-                                      </p:cBhvr>
-                                    </p:animEffect>
-                                  </p:childTnLst>
-                                </p:cTn>
-                              </p:par>
-                            </p:childTnLst>
-                          </p:cTn>
-                        </p:par>
-                      </p:childTnLst>
-                    </p:cTn>
-                  </p:par>
-                  <p:par>
-                    <p:cTn id="8" fill="hold">
-                      <p:stCondLst>
-                        <p:cond delay="indefinite"/>
-                      </p:stCondLst>
-                      <p:childTnLst>
-                        <p:par>
-                          <p:cTn id="9" fill="hold">
-                            <p:stCondLst>
-                              <p:cond delay="0"/>
-                            </p:stCondLst>
-                            <p:childTnLst>
-                              <p:par>
-                                <p:cTn id="10" presetID="10" presetClass="entr" presetSubtype="0" fill="hold" grpId="0" nodeType="clickEffect">
-                                  <p:stCondLst>
-                                    <p:cond delay="0"/>
-                                  </p:stCondLst>
-                                  <p:childTnLst>
-                                    <p:set>
-                                      <p:cBhvr>
-                                        <p:cTn id="11" dur="1" fill="hold">
-                                          <p:stCondLst>
-                                            <p:cond delay="0"/>
-                                          </p:stCondLst>
-                                        </p:cTn>
-                                        <p:tgtEl>
-                                          <p:spTgt spid="90">
-                                            <p:txEl>
-                                              <p:pRg st="1" end="1"/>
-                                            </p:txEl>
-                                          </p:spTgt>
-                                        </p:tgtEl>
-                                        <p:attrNameLst>
-                                          <p:attrName>style.visibility</p:attrName>
-                                        </p:attrNameLst>
-                                      </p:cBhvr>
-                                      <p:to>
-                                        <p:strVal val="visible"/>
-                                      </p:to>
-                                    </p:set>
-                                    <p:animEffect transition="in" filter="fade">
-                                      <p:cBhvr>
-                                        <p:cTn id="12" dur="500"/>
-                                        <p:tgtEl>
-                                          <p:spTgt spid="90">
-                                            <p:txEl>
-                                              <p:pRg st="1" end="1"/>
-                                            </p:txEl>
-                                          </p:spTgt>
-                                        </p:tgtEl>
-                                      </p:cBhvr>
-                                    </p:animEffect>
-                                  </p:childTnLst>
-                                </p:cTn>
-                              </p:par>
-                            </p:childTnLst>
-                          </p:cTn>
-                        </p:par>
-                      </p:childTnLst>
-                    </p:cTn>
-                  </p:par>
-                  <p:par>
-                    <p:cTn id="13" fill="hold">
-                      <p:stCondLst>
-                        <p:cond delay="indefinite"/>
-                      </p:stCondLst>
-                      <p:childTnLst>
-                        <p:par>
-                          <p:cTn id="14" fill="hold">
-                            <p:stCondLst>
-                              <p:cond delay="0"/>
-                            </p:stCondLst>
-                            <p:childTnLst>
-                              <p:par>
-                                <p:cTn id="15" presetID="10" presetClass="entr" presetSubtype="0" fill="hold" grpId="0" nodeType="clickEffect">
-                                  <p:stCondLst>
-                                    <p:cond delay="0"/>
-                                  </p:stCondLst>
-                                  <p:childTnLst>
-                                    <p:set>
-                                      <p:cBhvr>
-                                        <p:cTn id="16" dur="1" fill="hold">
-                                          <p:stCondLst>
-                                            <p:cond delay="0"/>
-                                          </p:stCondLst>
-                                        </p:cTn>
-                                        <p:tgtEl>
-                                          <p:spTgt spid="90">
-                                            <p:txEl>
-                                              <p:pRg st="2" end="2"/>
-                                            </p:txEl>
-                                          </p:spTgt>
-                                        </p:tgtEl>
-                                        <p:attrNameLst>
-                                          <p:attrName>style.visibility</p:attrName>
-                                        </p:attrNameLst>
-                                      </p:cBhvr>
-                                      <p:to>
-                                        <p:strVal val="visible"/>
-                                      </p:to>
-                                    </p:set>
-                                    <p:animEffect transition="in" filter="fade">
-                                      <p:cBhvr>
-                                        <p:cTn id="17" dur="500"/>
-                                        <p:tgtEl>
-                                          <p:spTgt spid="90">
-                                            <p:txEl>
-                                              <p:pRg st="2" end="2"/>
-                                            </p:txEl>
-                                          </p:spTgt>
-                                        </p:tgtEl>
-                                      </p:cBhvr>
-                                    </p:animEffect>
-                                  </p:childTnLst>
-                                </p:cTn>
-                              </p:par>
-                            </p:childTnLst>
-                          </p:cTn>
-                        </p:par>
-                      </p:childTnLst>
-                    </p:cTn>
-                  </p:par>
-                  <p:par>
-                    <p:cTn id="18" fill="hold">
-                      <p:stCondLst>
-                        <p:cond delay="indefinite"/>
-                      </p:stCondLst>
-                      <p:childTnLst>
-                        <p:par>
-                          <p:cTn id="19" fill="hold">
-                            <p:stCondLst>
-                              <p:cond delay="0"/>
-                            </p:stCondLst>
-                            <p:childTnLst>
-                              <p:par>
-                                <p:cTn id="20" presetID="10" presetClass="entr" presetSubtype="0" fill="hold" grpId="0" nodeType="clickEffect">
-                                  <p:stCondLst>
-                                    <p:cond delay="0"/>
-                                  </p:stCondLst>
-                                  <p:childTnLst>
-                                    <p:set>
-                                      <p:cBhvr>
-                                        <p:cTn id="21" dur="1" fill="hold">
-                                          <p:stCondLst>
-                                            <p:cond delay="0"/>
-                                          </p:stCondLst>
-                                        </p:cTn>
-                                        <p:tgtEl>
-                                          <p:spTgt spid="90">
-                                            <p:txEl>
-                                              <p:pRg st="3" end="3"/>
-                                            </p:txEl>
-                                          </p:spTgt>
-                                        </p:tgtEl>
-                                        <p:attrNameLst>
-                                          <p:attrName>style.visibility</p:attrName>
-                                        </p:attrNameLst>
-                                      </p:cBhvr>
-                                      <p:to>
-                                        <p:strVal val="visible"/>
-                                      </p:to>
-                                    </p:set>
-                                    <p:animEffect transition="in" filter="fade">
-                                      <p:cBhvr>
-                                        <p:cTn id="22" dur="500"/>
-                                        <p:tgtEl>
-                                          <p:spTgt spid="90">
-                                            <p:txEl>
-                                              <p:pRg st="3" end="3"/>
-                                            </p:txEl>
-                                          </p:spTgt>
-                                        </p:tgtEl>
-                                      </p:cBhvr>
-                                    </p:animEffect>
-                                  </p:childTnLst>
-                                </p:cTn>
-                              </p:par>
-                            </p:childTnLst>
-                          </p:cTn>
-                        </p:par>
-                      </p:childTnLst>
-                    </p:cTn>
-                  </p:par>
-                  <p:par>
-                    <p:cTn id="23" fill="hold">
-                      <p:stCondLst>
-                        <p:cond delay="indefinite"/>
-                      </p:stCondLst>
-                      <p:childTnLst>
-                        <p:par>
-                          <p:cTn id="24" fill="hold">
-                            <p:stCondLst>
-                              <p:cond delay="0"/>
-                            </p:stCondLst>
-                            <p:childTnLst>
-                              <p:par>
-                                <p:cTn id="25" presetID="10" presetClass="entr" presetSubtype="0" fill="hold" grpId="0" nodeType="clickEffect">
-                                  <p:stCondLst>
-                                    <p:cond delay="0"/>
-                                  </p:stCondLst>
-                                  <p:childTnLst>
-                                    <p:set>
-                                      <p:cBhvr>
-                                        <p:cTn id="26" dur="1" fill="hold">
-                                          <p:stCondLst>
-                                            <p:cond delay="0"/>
-                                          </p:stCondLst>
-                                        </p:cTn>
-                                        <p:tgtEl>
-                                          <p:spTgt spid="90">
-                                            <p:txEl>
-                                              <p:pRg st="4" end="4"/>
-                                            </p:txEl>
-                                          </p:spTgt>
-                                        </p:tgtEl>
-                                        <p:attrNameLst>
-                                          <p:attrName>style.visibility</p:attrName>
-                                        </p:attrNameLst>
-                                      </p:cBhvr>
-                                      <p:to>
-                                        <p:strVal val="visible"/>
-                                      </p:to>
-                                    </p:set>
-                                    <p:animEffect transition="in" filter="fade">
-                                      <p:cBhvr>
-                                        <p:cTn id="27" dur="500"/>
-                                        <p:tgtEl>
-                                          <p:spTgt spid="90">
-                                            <p:txEl>
-                                              <p:pRg st="4" end="4"/>
-                                            </p:txEl>
-                                          </p:spTgt>
-                                        </p:tgtEl>
-                                      </p:cBhvr>
-                                    </p:animEffect>
-                                  </p:childTnLst>
-                                </p:cTn>
-                              </p:par>
-                            </p:childTnLst>
-                          </p:cTn>
-                        </p:par>
-                      </p:childTnLst>
-                    </p:cTn>
-                  </p:par>
-                  <p:par>
-                    <p:cTn id="28" fill="hold">
-                      <p:stCondLst>
-                        <p:cond delay="indefinite"/>
-                      </p:stCondLst>
-                      <p:childTnLst>
-                        <p:par>
-                          <p:cTn id="29" fill="hold">
-                            <p:stCondLst>
-                              <p:cond delay="0"/>
-                            </p:stCondLst>
-                            <p:childTnLst>
-                              <p:par>
-                                <p:cTn id="30" presetID="10" presetClass="entr" presetSubtype="0" fill="hold" grpId="0" nodeType="clickEffect">
-                                  <p:stCondLst>
-                                    <p:cond delay="0"/>
-                                  </p:stCondLst>
-                                  <p:childTnLst>
-                                    <p:set>
-                                      <p:cBhvr>
-                                        <p:cTn id="31" dur="1" fill="hold">
-                                          <p:stCondLst>
-                                            <p:cond delay="0"/>
-                                          </p:stCondLst>
-                                        </p:cTn>
-                                        <p:tgtEl>
-                                          <p:spTgt spid="90">
-                                            <p:txEl>
-                                              <p:pRg st="5" end="5"/>
-                                            </p:txEl>
-                                          </p:spTgt>
-                                        </p:tgtEl>
-                                        <p:attrNameLst>
-                                          <p:attrName>style.visibility</p:attrName>
-                                        </p:attrNameLst>
-                                      </p:cBhvr>
-                                      <p:to>
-                                        <p:strVal val="visible"/>
-                                      </p:to>
-                                    </p:set>
-                                    <p:animEffect transition="in" filter="fade">
-                                      <p:cBhvr>
-                                        <p:cTn id="32" dur="500"/>
-                                        <p:tgtEl>
-                                          <p:spTgt spid="90">
-                                            <p:txEl>
-                                              <p:pRg st="5" end="5"/>
-                                            </p:txEl>
-                                          </p:spTgt>
-                                        </p:tgtEl>
-                                      </p:cBhvr>
-                                    </p:animEffect>
-                                  </p:childTnLst>
-                                </p:cTn>
-                              </p:par>
-                            </p:childTnLst>
-                          </p:cTn>
-                        </p:par>
-                      </p:childTnLst>
-                    </p:cTn>
-                  </p:par>
-                  <p:par>
-                    <p:cTn id="33" fill="hold">
-                      <p:stCondLst>
-                        <p:cond delay="indefinite"/>
-                      </p:stCondLst>
-                      <p:childTnLst>
-                        <p:par>
-                          <p:cTn id="34" fill="hold">
-                            <p:stCondLst>
-                              <p:cond delay="0"/>
-                            </p:stCondLst>
-                            <p:childTnLst>
-                              <p:par>
-                                <p:cTn id="35" presetID="10" presetClass="entr" presetSubtype="0" fill="hold" grpId="0" nodeType="clickEffect">
-                                  <p:stCondLst>
-                                    <p:cond delay="0"/>
-                                  </p:stCondLst>
-                                  <p:childTnLst>
-                                    <p:set>
-                                      <p:cBhvr>
-                                        <p:cTn id="36" dur="1" fill="hold">
-                                          <p:stCondLst>
-                                            <p:cond delay="0"/>
-                                          </p:stCondLst>
-                                        </p:cTn>
-                                        <p:tgtEl>
-                                          <p:spTgt spid="90">
-                                            <p:txEl>
-                                              <p:pRg st="6" end="6"/>
-                                            </p:txEl>
-                                          </p:spTgt>
-                                        </p:tgtEl>
-                                        <p:attrNameLst>
-                                          <p:attrName>style.visibility</p:attrName>
-                                        </p:attrNameLst>
-                                      </p:cBhvr>
-                                      <p:to>
-                                        <p:strVal val="visible"/>
-                                      </p:to>
-                                    </p:set>
-                                    <p:animEffect transition="in" filter="fade">
-                                      <p:cBhvr>
-                                        <p:cTn id="37" dur="500"/>
-                                        <p:tgtEl>
-                                          <p:spTgt spid="90">
-                                            <p:txEl>
-                                              <p:pRg st="6" end="6"/>
-                                            </p:txEl>
-                                          </p:spTgt>
-                                        </p:tgtEl>
-                                      </p:cBhvr>
-                                    </p:animEffect>
-                                  </p:childTnLst>
-                                </p:cTn>
-                              </p:par>
-                            </p:childTnLst>
-                          </p:cTn>
-                        </p:par>
-                      </p:childTnLst>
-                    </p:cTn>
-                  </p:par>
-                  <p:par>
-                    <p:cTn id="38" fill="hold">
-                      <p:stCondLst>
-                        <p:cond delay="indefinite"/>
-                      </p:stCondLst>
-                      <p:childTnLst>
-                        <p:par>
-                          <p:cTn id="39" fill="hold">
-                            <p:stCondLst>
-                              <p:cond delay="0"/>
-                            </p:stCondLst>
-                            <p:childTnLst>
-                              <p:par>
-                                <p:cTn id="40" presetID="10" presetClass="entr" presetSubtype="0" fill="hold" grpId="0" nodeType="clickEffect">
-                                  <p:stCondLst>
-                                    <p:cond delay="0"/>
-                                  </p:stCondLst>
-                                  <p:childTnLst>
-                                    <p:set>
-                                      <p:cBhvr>
-                                        <p:cTn id="41" dur="1" fill="hold">
-                                          <p:stCondLst>
-                                            <p:cond delay="0"/>
-                                          </p:stCondLst>
-                                        </p:cTn>
-                                        <p:tgtEl>
-                                          <p:spTgt spid="90">
-                                            <p:txEl>
-                                              <p:pRg st="7" end="7"/>
-                                            </p:txEl>
-                                          </p:spTgt>
-                                        </p:tgtEl>
-                                        <p:attrNameLst>
-                                          <p:attrName>style.visibility</p:attrName>
-                                        </p:attrNameLst>
-                                      </p:cBhvr>
-                                      <p:to>
-                                        <p:strVal val="visible"/>
-                                      </p:to>
-                                    </p:set>
-                                    <p:animEffect transition="in" filter="fade">
-                                      <p:cBhvr>
-                                        <p:cTn id="42" dur="500"/>
-                                        <p:tgtEl>
-                                          <p:spTgt spid="90">
-                                            <p:txEl>
-                                              <p:pRg st="7" end="7"/>
-                                            </p:txEl>
-                                          </p:spTgt>
-                                        </p:tgtEl>
-                                      </p:cBhvr>
-                                    </p:animEffect>
-                                  </p:childTnLst>
-                                </p:cTn>
-                              </p:par>
-                            </p:childTnLst>
-                          </p:cTn>
-                        </p:par>
-                      </p:childTnLst>
-                    </p:cTn>
-                  </p:par>
-                </p:childTnLst>
-              </p:cTn>
-              <p:prevCondLst>
-                <p:cond evt="onPrev" delay="0">
-                  <p:tgtEl>
-                    <p:sldTgt/>
-                  </p:tgtEl>
-                </p:cond>
-              </p:prevCondLst>
-              <p:nextCondLst>
-                <p:cond evt="onNext" delay="0">
-                  <p:tgtEl>
-                    <p:sldTgt/>
-                  </p:tgtEl>
-                </p:cond>
-              </p:nextCondLst>
-            </p:seq>
-          </p:childTnLst>
-        </p:cTn>
-      </p:par>
-    </p:tnLst>
-    <p:bldLst>
-      <p:bldP spid="90" grpId="0" build="p"/>
-    </p:bldLst>
-  </p:timing>
-</p:sld>
-</file>
-
-<file path=ppt/slides/slide18.xml><?xml version="1.0" encoding="utf-8"?>
-<p:sld xmlns:a="http://schemas.openxmlformats.org/drawingml/2006/main" xmlns:r="http://schemas.openxmlformats.org/officeDocument/2006/relationships" xmlns:p="http://schemas.openxmlformats.org/presentationml/2006/main">
-  <p:cSld>
-    <p:spTree>
-      <p:nvGrpSpPr>
-        <p:cNvPr id="1" name=""/>
-        <p:cNvGrpSpPr/>
-        <p:nvPr/>
-      </p:nvGrpSpPr>
-      <p:grpSpPr>
-        <a:xfrm>
-          <a:off x="0" y="0"/>
-          <a:ext cx="0" cy="0"/>
-          <a:chOff x="0" y="0"/>
-          <a:chExt cx="0" cy="0"/>
-        </a:xfrm>
-      </p:grpSpPr>
-      <p:sp>
-        <p:nvSpPr>
-          <p:cNvPr id="5" name="TextBox 4">
-            <a:extLst>
-              <a:ext uri="{FF2B5EF4-FFF2-40B4-BE49-F238E27FC236}">
-                <a16:creationId xmlns:a16="http://schemas.microsoft.com/office/drawing/2014/main" id="{F13B2D6E-876F-C265-35AB-5F85CF521009}"/>
-              </a:ext>
-            </a:extLst>
-          </p:cNvPr>
-          <p:cNvSpPr txBox="1"/>
-          <p:nvPr/>
-        </p:nvSpPr>
-        <p:spPr>
-          <a:xfrm>
-            <a:off x="685800" y="360000"/>
-            <a:ext cx="7772400" cy="600000"/>
-          </a:xfrm>
-          <a:prstGeom prst="rect">
-            <a:avLst/>
-          </a:prstGeom>
-          <a:noFill/>
-        </p:spPr>
-        <p:txBody>
-          <a:bodyPr wrap="square">
-            <a:spAutoFit/>
-          </a:bodyPr>
-          <a:lstStyle/>
-          <a:p>
-            <a:pPr marL="0" lvl="0" indent="0" algn="ctr">
-              <a:lnSpc>
-                <a:spcPct val="115000"/>
-              </a:lnSpc>
-              <a:spcBef>
-                <a:spcPts val="600"/>
-              </a:spcBef>
-              <a:buSzPts val="1800"/>
-            </a:pPr>
-            <a:r>
-              <a:rPr lang="en-US" sz="1400" b="1" dirty="0"/>
-              <a:t>Questions?  |  </a:t>
-            </a:r>
-            <a:r>
-              <a:rPr lang="en-US" b="1" dirty="0"/>
-              <a:t>https://</a:t>
-            </a:r>
-            <a:r>
-              <a:rPr lang="en-US" b="1" dirty="0" err="1"/>
-              <a:t>github.com</a:t>
-            </a:r>
-            <a:r>
-              <a:rPr lang="en-US" b="1" dirty="0"/>
-              <a:t>/ram2valar/</a:t>
-            </a:r>
-            <a:r>
-              <a:rPr lang="en-US" b="1" dirty="0" err="1"/>
-              <a:t>kubeflow</a:t>
-            </a:r>
-            <a:r>
-              <a:rPr lang="en-US" b="1" dirty="0"/>
-              <a:t>-cilium-lab</a:t>
-            </a:r>
-            <a:endParaRPr lang="en-US" dirty="0"/>
-          </a:p>
-        </p:txBody>
-      </p:sp>
-      <p:pic>
-        <p:nvPicPr>
-          <p:cNvPr id="20" name="Ramkumar Nagaraj QR"/>
-          <p:cNvPicPr>
-            <a:picLocks noChangeAspect="1"/>
-          </p:cNvPicPr>
-          <p:nvPr/>
-        </p:nvPicPr>
-        <p:blipFill>
-          <a:blip r:embed="rId2"/>
-          <a:stretch>
-            <a:fillRect/>
-          </a:stretch>
-        </p:blipFill>
-        <p:spPr>
-          <a:xfrm>
-            <a:off x="1498900" y="1520000"/>
-            <a:ext cx="2657000" cy="2926080"/>
-          </a:xfrm>
-          <a:prstGeom prst="rect">
-            <a:avLst/>
-          </a:prstGeom>
-        </p:spPr>
-      </p:pic>
-      <p:pic>
-        <p:nvPicPr>
-          <p:cNvPr id="21" name="Bingi Narasimha Karthik QR"/>
-          <p:cNvPicPr>
-            <a:picLocks noChangeAspect="1"/>
-          </p:cNvPicPr>
-          <p:nvPr/>
-        </p:nvPicPr>
-        <p:blipFill>
-          <a:blip r:embed="rId3"/>
-          <a:stretch>
-            <a:fillRect/>
-          </a:stretch>
-        </p:blipFill>
-        <p:spPr>
-          <a:xfrm>
-            <a:off x="4613100" y="1520000"/>
-            <a:ext cx="3032000" cy="2926080"/>
-          </a:xfrm>
-          <a:prstGeom prst="rect">
-            <a:avLst/>
-          </a:prstGeom>
-        </p:spPr>
-      </p:pic>
-    </p:spTree>
-    <p:extLst>
-      <p:ext uri="{BB962C8B-B14F-4D97-AF65-F5344CB8AC3E}">
-        <p14:creationId xmlns:p14="http://schemas.microsoft.com/office/powerpoint/2010/main" val="1534186562"/>
       </p:ext>
     </p:extLst>
   </p:cSld>
@@ -12636,7 +11783,7 @@
         </p:nvSpPr>
         <p:spPr>
           <a:xfrm>
-            <a:off x="311700" y="445025"/>
+            <a:off x="311700" y="170066"/>
             <a:ext cx="8520600" cy="572700"/>
           </a:xfrm>
           <a:prstGeom prst="rect">
@@ -12670,7 +11817,7 @@
               <a:rPr lang="en-US" sz="2800" b="1" dirty="0"/>
               <a:t>Beyond the Hard Block: The Production Spectrum</a:t>
             </a:r>
-            <a:endParaRPr/>
+            <a:endParaRPr dirty="0"/>
           </a:p>
         </p:txBody>
       </p:sp>
@@ -12686,7 +11833,7 @@
         </p:nvSpPr>
         <p:spPr>
           <a:xfrm>
-            <a:off x="311700" y="1152475"/>
+            <a:off x="311700" y="913050"/>
             <a:ext cx="8520600" cy="3317400"/>
           </a:xfrm>
           <a:prstGeom prst="rect">
@@ -13464,7 +12611,7 @@
         </p:nvSpPr>
         <p:spPr>
           <a:xfrm>
-            <a:off x="311700" y="1152475"/>
+            <a:off x="362856" y="1171658"/>
             <a:ext cx="8520600" cy="3317400"/>
           </a:xfrm>
           <a:prstGeom prst="rect">
@@ -13594,7 +12741,7 @@
               <a:rPr lang="en-US" sz="2000" b="0" dirty="0"/>
               <a:t>— General patterns for CNI-aware ML scheduling</a:t>
             </a:r>
-            <a:endParaRPr/>
+            <a:endParaRPr dirty="0"/>
           </a:p>
         </p:txBody>
       </p:sp>
@@ -13944,6 +13091,927 @@
 </p:sld>
 </file>
 
+<file path=ppt/slides/slide20.xml><?xml version="1.0" encoding="utf-8"?>
+<p:sld xmlns:a="http://schemas.openxmlformats.org/drawingml/2006/main" xmlns:r="http://schemas.openxmlformats.org/officeDocument/2006/relationships" xmlns:p="http://schemas.openxmlformats.org/presentationml/2006/main">
+  <p:cSld>
+    <p:spTree>
+      <p:nvGrpSpPr>
+        <p:cNvPr id="1" name="Shape 88"/>
+        <p:cNvGrpSpPr/>
+        <p:nvPr/>
+      </p:nvGrpSpPr>
+      <p:grpSpPr>
+        <a:xfrm>
+          <a:off x="0" y="0"/>
+          <a:ext cx="0" cy="0"/>
+          <a:chOff x="0" y="0"/>
+          <a:chExt cx="0" cy="0"/>
+        </a:xfrm>
+      </p:grpSpPr>
+      <p:sp>
+        <p:nvSpPr>
+          <p:cNvPr id="89" name="Google Shape;89;p5"/>
+          <p:cNvSpPr txBox="1">
+            <a:spLocks noGrp="1"/>
+          </p:cNvSpPr>
+          <p:nvPr>
+            <p:ph type="title"/>
+          </p:nvPr>
+        </p:nvSpPr>
+        <p:spPr>
+          <a:xfrm>
+            <a:off x="311700" y="221221"/>
+            <a:ext cx="8520600" cy="572700"/>
+          </a:xfrm>
+          <a:prstGeom prst="rect">
+            <a:avLst/>
+          </a:prstGeom>
+          <a:noFill/>
+          <a:ln>
+            <a:noFill/>
+          </a:ln>
+        </p:spPr>
+        <p:txBody>
+          <a:bodyPr spcFirstLastPara="1" wrap="square" lIns="0" tIns="0" rIns="0" bIns="0" anchor="ctr" anchorCtr="0">
+            <a:normAutofit/>
+          </a:bodyPr>
+          <a:lstStyle/>
+          <a:p>
+            <a:pPr marL="0" lvl="0" indent="0" algn="l" rtl="0">
+              <a:lnSpc>
+                <a:spcPct val="100000"/>
+              </a:lnSpc>
+              <a:spcBef>
+                <a:spcPts val="0"/>
+              </a:spcBef>
+              <a:spcAft>
+                <a:spcPts val="0"/>
+              </a:spcAft>
+              <a:buSzPts val="2800"/>
+              <a:buNone/>
+            </a:pPr>
+            <a:r>
+              <a:rPr lang="en-US" sz="2800" b="1" dirty="0"/>
+              <a:t>Key Takeaways</a:t>
+            </a:r>
+            <a:endParaRPr dirty="0"/>
+          </a:p>
+        </p:txBody>
+      </p:sp>
+      <p:sp>
+        <p:nvSpPr>
+          <p:cNvPr id="90" name="Google Shape;90;p5"/>
+          <p:cNvSpPr txBox="1">
+            <a:spLocks noGrp="1"/>
+          </p:cNvSpPr>
+          <p:nvPr>
+            <p:ph type="body" idx="1"/>
+          </p:nvPr>
+        </p:nvSpPr>
+        <p:spPr>
+          <a:xfrm>
+            <a:off x="311700" y="999009"/>
+            <a:ext cx="8520600" cy="3317400"/>
+          </a:xfrm>
+          <a:prstGeom prst="rect">
+            <a:avLst/>
+          </a:prstGeom>
+          <a:noFill/>
+          <a:ln>
+            <a:noFill/>
+          </a:ln>
+        </p:spPr>
+        <p:txBody>
+          <a:bodyPr spcFirstLastPara="1" wrap="square" lIns="0" tIns="0" rIns="0" bIns="0" anchor="t" anchorCtr="0">
+            <a:noAutofit/>
+          </a:bodyPr>
+          <a:lstStyle/>
+          <a:p>
+            <a:pPr marL="457200" lvl="0" indent="-228600" algn="l" rtl="0">
+              <a:lnSpc>
+                <a:spcPct val="115000"/>
+              </a:lnSpc>
+              <a:spcBef>
+                <a:spcPts val="0"/>
+              </a:spcBef>
+              <a:spcAft>
+                <a:spcPts val="0"/>
+              </a:spcAft>
+              <a:buSzPts val="1800"/>
+              <a:buNone/>
+            </a:pPr>
+            <a:r>
+              <a:rPr lang="en-US" sz="1900" b="1" dirty="0"/>
+              <a:t>1. Your CNI has opinions about topology — your scheduler doesn’t know</a:t>
+            </a:r>
+          </a:p>
+          <a:p>
+            <a:pPr marL="457200" lvl="0" indent="-228600" algn="l" rtl="0">
+              <a:lnSpc>
+                <a:spcPct val="115000"/>
+              </a:lnSpc>
+              <a:spcBef>
+                <a:spcPts val="100"/>
+              </a:spcBef>
+              <a:spcAft>
+                <a:spcPts val="0"/>
+              </a:spcAft>
+              <a:buSzPts val="1800"/>
+              <a:buNone/>
+            </a:pPr>
+            <a:r>
+              <a:rPr lang="en-US" sz="1600" b="0" dirty="0"/>
+              <a:t>Cilium topology-aware policies are silent to the Kubernetes scheduler</a:t>
+            </a:r>
+          </a:p>
+          <a:p>
+            <a:pPr marL="457200" lvl="0" indent="-228600" algn="l" rtl="0">
+              <a:lnSpc>
+                <a:spcPct val="115000"/>
+              </a:lnSpc>
+              <a:spcBef>
+                <a:spcPts val="400"/>
+              </a:spcBef>
+              <a:spcAft>
+                <a:spcPts val="0"/>
+              </a:spcAft>
+              <a:buSzPts val="1800"/>
+              <a:buNone/>
+            </a:pPr>
+            <a:r>
+              <a:rPr lang="en-US" sz="1900" b="1" dirty="0"/>
+              <a:t>2. Topology spread constraints = Kubernetes-native fix</a:t>
+            </a:r>
+          </a:p>
+          <a:p>
+            <a:pPr marL="457200" lvl="0" indent="-228600" algn="l" rtl="0">
+              <a:lnSpc>
+                <a:spcPct val="115000"/>
+              </a:lnSpc>
+              <a:spcBef>
+                <a:spcPts val="100"/>
+              </a:spcBef>
+              <a:spcAft>
+                <a:spcPts val="0"/>
+              </a:spcAft>
+              <a:buSzPts val="1800"/>
+              <a:buNone/>
+            </a:pPr>
+            <a:r>
+              <a:rPr lang="en-US" sz="1600" b="0" dirty="0"/>
+              <a:t>No Kubeflow patch, no Cilium change — 3 YAML stanzas in your workload spec</a:t>
+            </a:r>
+          </a:p>
+          <a:p>
+            <a:pPr marL="457200" lvl="0" indent="-228600" algn="l" rtl="0">
+              <a:lnSpc>
+                <a:spcPct val="115000"/>
+              </a:lnSpc>
+              <a:spcBef>
+                <a:spcPts val="400"/>
+              </a:spcBef>
+              <a:spcAft>
+                <a:spcPts val="0"/>
+              </a:spcAft>
+              <a:buSzPts val="1800"/>
+              <a:buNone/>
+            </a:pPr>
+            <a:r>
+              <a:rPr lang="en-US" sz="1900" b="1" dirty="0"/>
+              <a:t>3. Instrument before you need it: GPU utilization + pod zone metrics</a:t>
+            </a:r>
+          </a:p>
+          <a:p>
+            <a:pPr marL="457200" lvl="0" indent="-228600" algn="l" rtl="0">
+              <a:lnSpc>
+                <a:spcPct val="115000"/>
+              </a:lnSpc>
+              <a:spcBef>
+                <a:spcPts val="100"/>
+              </a:spcBef>
+              <a:spcAft>
+                <a:spcPts val="0"/>
+              </a:spcAft>
+              <a:buSzPts val="1800"/>
+              <a:buNone/>
+            </a:pPr>
+            <a:r>
+              <a:rPr lang="en-US" sz="1600" b="0" dirty="0"/>
+              <a:t>Prometheus + Grafana dashboards exposed this in seconds, not days</a:t>
+            </a:r>
+          </a:p>
+          <a:p>
+            <a:pPr marL="457200" lvl="0" indent="-228600" algn="l" rtl="0">
+              <a:lnSpc>
+                <a:spcPct val="115000"/>
+              </a:lnSpc>
+              <a:spcBef>
+                <a:spcPts val="400"/>
+              </a:spcBef>
+              <a:spcAft>
+                <a:spcPts val="0"/>
+              </a:spcAft>
+              <a:buSzPts val="1800"/>
+              <a:buNone/>
+            </a:pPr>
+            <a:r>
+              <a:rPr lang="en-US" sz="1900" b="1" dirty="0"/>
+              <a:t>4. Pattern applies beyond Kubeflow/Cilium</a:t>
+            </a:r>
+          </a:p>
+          <a:p>
+            <a:pPr marL="457200" lvl="0" indent="-228600" algn="l" rtl="0">
+              <a:lnSpc>
+                <a:spcPct val="115000"/>
+              </a:lnSpc>
+              <a:spcBef>
+                <a:spcPts val="100"/>
+              </a:spcBef>
+              <a:spcAft>
+                <a:spcPts val="0"/>
+              </a:spcAft>
+              <a:buSzPts val="1800"/>
+              <a:buNone/>
+            </a:pPr>
+            <a:r>
+              <a:rPr lang="en-US" sz="1600" b="0" dirty="0"/>
+              <a:t>Same root cause, 3 faces in prod: hard Cilium block, cross-zone NCCL latency, cross-AZ egress cost</a:t>
+            </a:r>
+          </a:p>
+        </p:txBody>
+      </p:sp>
+    </p:spTree>
+  </p:cSld>
+  <p:clrMapOvr>
+    <a:masterClrMapping/>
+  </p:clrMapOvr>
+  <p:timing>
+    <p:tnLst>
+      <p:par>
+        <p:cTn id="1" dur="indefinite" restart="never" nodeType="tmRoot">
+          <p:childTnLst>
+            <p:seq concurrent="1" nextAc="seek">
+              <p:cTn id="2" dur="indefinite" nodeType="mainSeq">
+                <p:childTnLst>
+                  <p:par>
+                    <p:cTn id="3" fill="hold">
+                      <p:stCondLst>
+                        <p:cond delay="indefinite"/>
+                      </p:stCondLst>
+                      <p:childTnLst>
+                        <p:par>
+                          <p:cTn id="4" fill="hold">
+                            <p:stCondLst>
+                              <p:cond delay="0"/>
+                            </p:stCondLst>
+                            <p:childTnLst>
+                              <p:par>
+                                <p:cTn id="5" presetID="10" presetClass="entr" presetSubtype="0" fill="hold" grpId="0" nodeType="clickEffect">
+                                  <p:stCondLst>
+                                    <p:cond delay="0"/>
+                                  </p:stCondLst>
+                                  <p:childTnLst>
+                                    <p:set>
+                                      <p:cBhvr>
+                                        <p:cTn id="6" dur="1" fill="hold">
+                                          <p:stCondLst>
+                                            <p:cond delay="0"/>
+                                          </p:stCondLst>
+                                        </p:cTn>
+                                        <p:tgtEl>
+                                          <p:spTgt spid="90">
+                                            <p:txEl>
+                                              <p:pRg st="0" end="0"/>
+                                            </p:txEl>
+                                          </p:spTgt>
+                                        </p:tgtEl>
+                                        <p:attrNameLst>
+                                          <p:attrName>style.visibility</p:attrName>
+                                        </p:attrNameLst>
+                                      </p:cBhvr>
+                                      <p:to>
+                                        <p:strVal val="visible"/>
+                                      </p:to>
+                                    </p:set>
+                                    <p:animEffect transition="in" filter="fade">
+                                      <p:cBhvr>
+                                        <p:cTn id="7" dur="500"/>
+                                        <p:tgtEl>
+                                          <p:spTgt spid="90">
+                                            <p:txEl>
+                                              <p:pRg st="0" end="0"/>
+                                            </p:txEl>
+                                          </p:spTgt>
+                                        </p:tgtEl>
+                                      </p:cBhvr>
+                                    </p:animEffect>
+                                  </p:childTnLst>
+                                </p:cTn>
+                              </p:par>
+                            </p:childTnLst>
+                          </p:cTn>
+                        </p:par>
+                      </p:childTnLst>
+                    </p:cTn>
+                  </p:par>
+                  <p:par>
+                    <p:cTn id="8" fill="hold">
+                      <p:stCondLst>
+                        <p:cond delay="indefinite"/>
+                      </p:stCondLst>
+                      <p:childTnLst>
+                        <p:par>
+                          <p:cTn id="9" fill="hold">
+                            <p:stCondLst>
+                              <p:cond delay="0"/>
+                            </p:stCondLst>
+                            <p:childTnLst>
+                              <p:par>
+                                <p:cTn id="10" presetID="10" presetClass="entr" presetSubtype="0" fill="hold" grpId="0" nodeType="clickEffect">
+                                  <p:stCondLst>
+                                    <p:cond delay="0"/>
+                                  </p:stCondLst>
+                                  <p:childTnLst>
+                                    <p:set>
+                                      <p:cBhvr>
+                                        <p:cTn id="11" dur="1" fill="hold">
+                                          <p:stCondLst>
+                                            <p:cond delay="0"/>
+                                          </p:stCondLst>
+                                        </p:cTn>
+                                        <p:tgtEl>
+                                          <p:spTgt spid="90">
+                                            <p:txEl>
+                                              <p:pRg st="1" end="1"/>
+                                            </p:txEl>
+                                          </p:spTgt>
+                                        </p:tgtEl>
+                                        <p:attrNameLst>
+                                          <p:attrName>style.visibility</p:attrName>
+                                        </p:attrNameLst>
+                                      </p:cBhvr>
+                                      <p:to>
+                                        <p:strVal val="visible"/>
+                                      </p:to>
+                                    </p:set>
+                                    <p:animEffect transition="in" filter="fade">
+                                      <p:cBhvr>
+                                        <p:cTn id="12" dur="500"/>
+                                        <p:tgtEl>
+                                          <p:spTgt spid="90">
+                                            <p:txEl>
+                                              <p:pRg st="1" end="1"/>
+                                            </p:txEl>
+                                          </p:spTgt>
+                                        </p:tgtEl>
+                                      </p:cBhvr>
+                                    </p:animEffect>
+                                  </p:childTnLst>
+                                </p:cTn>
+                              </p:par>
+                            </p:childTnLst>
+                          </p:cTn>
+                        </p:par>
+                      </p:childTnLst>
+                    </p:cTn>
+                  </p:par>
+                  <p:par>
+                    <p:cTn id="13" fill="hold">
+                      <p:stCondLst>
+                        <p:cond delay="indefinite"/>
+                      </p:stCondLst>
+                      <p:childTnLst>
+                        <p:par>
+                          <p:cTn id="14" fill="hold">
+                            <p:stCondLst>
+                              <p:cond delay="0"/>
+                            </p:stCondLst>
+                            <p:childTnLst>
+                              <p:par>
+                                <p:cTn id="15" presetID="10" presetClass="entr" presetSubtype="0" fill="hold" grpId="0" nodeType="clickEffect">
+                                  <p:stCondLst>
+                                    <p:cond delay="0"/>
+                                  </p:stCondLst>
+                                  <p:childTnLst>
+                                    <p:set>
+                                      <p:cBhvr>
+                                        <p:cTn id="16" dur="1" fill="hold">
+                                          <p:stCondLst>
+                                            <p:cond delay="0"/>
+                                          </p:stCondLst>
+                                        </p:cTn>
+                                        <p:tgtEl>
+                                          <p:spTgt spid="90">
+                                            <p:txEl>
+                                              <p:pRg st="2" end="2"/>
+                                            </p:txEl>
+                                          </p:spTgt>
+                                        </p:tgtEl>
+                                        <p:attrNameLst>
+                                          <p:attrName>style.visibility</p:attrName>
+                                        </p:attrNameLst>
+                                      </p:cBhvr>
+                                      <p:to>
+                                        <p:strVal val="visible"/>
+                                      </p:to>
+                                    </p:set>
+                                    <p:animEffect transition="in" filter="fade">
+                                      <p:cBhvr>
+                                        <p:cTn id="17" dur="500"/>
+                                        <p:tgtEl>
+                                          <p:spTgt spid="90">
+                                            <p:txEl>
+                                              <p:pRg st="2" end="2"/>
+                                            </p:txEl>
+                                          </p:spTgt>
+                                        </p:tgtEl>
+                                      </p:cBhvr>
+                                    </p:animEffect>
+                                  </p:childTnLst>
+                                </p:cTn>
+                              </p:par>
+                            </p:childTnLst>
+                          </p:cTn>
+                        </p:par>
+                      </p:childTnLst>
+                    </p:cTn>
+                  </p:par>
+                  <p:par>
+                    <p:cTn id="18" fill="hold">
+                      <p:stCondLst>
+                        <p:cond delay="indefinite"/>
+                      </p:stCondLst>
+                      <p:childTnLst>
+                        <p:par>
+                          <p:cTn id="19" fill="hold">
+                            <p:stCondLst>
+                              <p:cond delay="0"/>
+                            </p:stCondLst>
+                            <p:childTnLst>
+                              <p:par>
+                                <p:cTn id="20" presetID="10" presetClass="entr" presetSubtype="0" fill="hold" grpId="0" nodeType="clickEffect">
+                                  <p:stCondLst>
+                                    <p:cond delay="0"/>
+                                  </p:stCondLst>
+                                  <p:childTnLst>
+                                    <p:set>
+                                      <p:cBhvr>
+                                        <p:cTn id="21" dur="1" fill="hold">
+                                          <p:stCondLst>
+                                            <p:cond delay="0"/>
+                                          </p:stCondLst>
+                                        </p:cTn>
+                                        <p:tgtEl>
+                                          <p:spTgt spid="90">
+                                            <p:txEl>
+                                              <p:pRg st="3" end="3"/>
+                                            </p:txEl>
+                                          </p:spTgt>
+                                        </p:tgtEl>
+                                        <p:attrNameLst>
+                                          <p:attrName>style.visibility</p:attrName>
+                                        </p:attrNameLst>
+                                      </p:cBhvr>
+                                      <p:to>
+                                        <p:strVal val="visible"/>
+                                      </p:to>
+                                    </p:set>
+                                    <p:animEffect transition="in" filter="fade">
+                                      <p:cBhvr>
+                                        <p:cTn id="22" dur="500"/>
+                                        <p:tgtEl>
+                                          <p:spTgt spid="90">
+                                            <p:txEl>
+                                              <p:pRg st="3" end="3"/>
+                                            </p:txEl>
+                                          </p:spTgt>
+                                        </p:tgtEl>
+                                      </p:cBhvr>
+                                    </p:animEffect>
+                                  </p:childTnLst>
+                                </p:cTn>
+                              </p:par>
+                            </p:childTnLst>
+                          </p:cTn>
+                        </p:par>
+                      </p:childTnLst>
+                    </p:cTn>
+                  </p:par>
+                  <p:par>
+                    <p:cTn id="23" fill="hold">
+                      <p:stCondLst>
+                        <p:cond delay="indefinite"/>
+                      </p:stCondLst>
+                      <p:childTnLst>
+                        <p:par>
+                          <p:cTn id="24" fill="hold">
+                            <p:stCondLst>
+                              <p:cond delay="0"/>
+                            </p:stCondLst>
+                            <p:childTnLst>
+                              <p:par>
+                                <p:cTn id="25" presetID="10" presetClass="entr" presetSubtype="0" fill="hold" grpId="0" nodeType="clickEffect">
+                                  <p:stCondLst>
+                                    <p:cond delay="0"/>
+                                  </p:stCondLst>
+                                  <p:childTnLst>
+                                    <p:set>
+                                      <p:cBhvr>
+                                        <p:cTn id="26" dur="1" fill="hold">
+                                          <p:stCondLst>
+                                            <p:cond delay="0"/>
+                                          </p:stCondLst>
+                                        </p:cTn>
+                                        <p:tgtEl>
+                                          <p:spTgt spid="90">
+                                            <p:txEl>
+                                              <p:pRg st="4" end="4"/>
+                                            </p:txEl>
+                                          </p:spTgt>
+                                        </p:tgtEl>
+                                        <p:attrNameLst>
+                                          <p:attrName>style.visibility</p:attrName>
+                                        </p:attrNameLst>
+                                      </p:cBhvr>
+                                      <p:to>
+                                        <p:strVal val="visible"/>
+                                      </p:to>
+                                    </p:set>
+                                    <p:animEffect transition="in" filter="fade">
+                                      <p:cBhvr>
+                                        <p:cTn id="27" dur="500"/>
+                                        <p:tgtEl>
+                                          <p:spTgt spid="90">
+                                            <p:txEl>
+                                              <p:pRg st="4" end="4"/>
+                                            </p:txEl>
+                                          </p:spTgt>
+                                        </p:tgtEl>
+                                      </p:cBhvr>
+                                    </p:animEffect>
+                                  </p:childTnLst>
+                                </p:cTn>
+                              </p:par>
+                            </p:childTnLst>
+                          </p:cTn>
+                        </p:par>
+                      </p:childTnLst>
+                    </p:cTn>
+                  </p:par>
+                  <p:par>
+                    <p:cTn id="28" fill="hold">
+                      <p:stCondLst>
+                        <p:cond delay="indefinite"/>
+                      </p:stCondLst>
+                      <p:childTnLst>
+                        <p:par>
+                          <p:cTn id="29" fill="hold">
+                            <p:stCondLst>
+                              <p:cond delay="0"/>
+                            </p:stCondLst>
+                            <p:childTnLst>
+                              <p:par>
+                                <p:cTn id="30" presetID="10" presetClass="entr" presetSubtype="0" fill="hold" grpId="0" nodeType="clickEffect">
+                                  <p:stCondLst>
+                                    <p:cond delay="0"/>
+                                  </p:stCondLst>
+                                  <p:childTnLst>
+                                    <p:set>
+                                      <p:cBhvr>
+                                        <p:cTn id="31" dur="1" fill="hold">
+                                          <p:stCondLst>
+                                            <p:cond delay="0"/>
+                                          </p:stCondLst>
+                                        </p:cTn>
+                                        <p:tgtEl>
+                                          <p:spTgt spid="90">
+                                            <p:txEl>
+                                              <p:pRg st="5" end="5"/>
+                                            </p:txEl>
+                                          </p:spTgt>
+                                        </p:tgtEl>
+                                        <p:attrNameLst>
+                                          <p:attrName>style.visibility</p:attrName>
+                                        </p:attrNameLst>
+                                      </p:cBhvr>
+                                      <p:to>
+                                        <p:strVal val="visible"/>
+                                      </p:to>
+                                    </p:set>
+                                    <p:animEffect transition="in" filter="fade">
+                                      <p:cBhvr>
+                                        <p:cTn id="32" dur="500"/>
+                                        <p:tgtEl>
+                                          <p:spTgt spid="90">
+                                            <p:txEl>
+                                              <p:pRg st="5" end="5"/>
+                                            </p:txEl>
+                                          </p:spTgt>
+                                        </p:tgtEl>
+                                      </p:cBhvr>
+                                    </p:animEffect>
+                                  </p:childTnLst>
+                                </p:cTn>
+                              </p:par>
+                            </p:childTnLst>
+                          </p:cTn>
+                        </p:par>
+                      </p:childTnLst>
+                    </p:cTn>
+                  </p:par>
+                  <p:par>
+                    <p:cTn id="33" fill="hold">
+                      <p:stCondLst>
+                        <p:cond delay="indefinite"/>
+                      </p:stCondLst>
+                      <p:childTnLst>
+                        <p:par>
+                          <p:cTn id="34" fill="hold">
+                            <p:stCondLst>
+                              <p:cond delay="0"/>
+                            </p:stCondLst>
+                            <p:childTnLst>
+                              <p:par>
+                                <p:cTn id="35" presetID="10" presetClass="entr" presetSubtype="0" fill="hold" grpId="0" nodeType="clickEffect">
+                                  <p:stCondLst>
+                                    <p:cond delay="0"/>
+                                  </p:stCondLst>
+                                  <p:childTnLst>
+                                    <p:set>
+                                      <p:cBhvr>
+                                        <p:cTn id="36" dur="1" fill="hold">
+                                          <p:stCondLst>
+                                            <p:cond delay="0"/>
+                                          </p:stCondLst>
+                                        </p:cTn>
+                                        <p:tgtEl>
+                                          <p:spTgt spid="90">
+                                            <p:txEl>
+                                              <p:pRg st="6" end="6"/>
+                                            </p:txEl>
+                                          </p:spTgt>
+                                        </p:tgtEl>
+                                        <p:attrNameLst>
+                                          <p:attrName>style.visibility</p:attrName>
+                                        </p:attrNameLst>
+                                      </p:cBhvr>
+                                      <p:to>
+                                        <p:strVal val="visible"/>
+                                      </p:to>
+                                    </p:set>
+                                    <p:animEffect transition="in" filter="fade">
+                                      <p:cBhvr>
+                                        <p:cTn id="37" dur="500"/>
+                                        <p:tgtEl>
+                                          <p:spTgt spid="90">
+                                            <p:txEl>
+                                              <p:pRg st="6" end="6"/>
+                                            </p:txEl>
+                                          </p:spTgt>
+                                        </p:tgtEl>
+                                      </p:cBhvr>
+                                    </p:animEffect>
+                                  </p:childTnLst>
+                                </p:cTn>
+                              </p:par>
+                            </p:childTnLst>
+                          </p:cTn>
+                        </p:par>
+                      </p:childTnLst>
+                    </p:cTn>
+                  </p:par>
+                  <p:par>
+                    <p:cTn id="38" fill="hold">
+                      <p:stCondLst>
+                        <p:cond delay="indefinite"/>
+                      </p:stCondLst>
+                      <p:childTnLst>
+                        <p:par>
+                          <p:cTn id="39" fill="hold">
+                            <p:stCondLst>
+                              <p:cond delay="0"/>
+                            </p:stCondLst>
+                            <p:childTnLst>
+                              <p:par>
+                                <p:cTn id="40" presetID="10" presetClass="entr" presetSubtype="0" fill="hold" grpId="0" nodeType="clickEffect">
+                                  <p:stCondLst>
+                                    <p:cond delay="0"/>
+                                  </p:stCondLst>
+                                  <p:childTnLst>
+                                    <p:set>
+                                      <p:cBhvr>
+                                        <p:cTn id="41" dur="1" fill="hold">
+                                          <p:stCondLst>
+                                            <p:cond delay="0"/>
+                                          </p:stCondLst>
+                                        </p:cTn>
+                                        <p:tgtEl>
+                                          <p:spTgt spid="90">
+                                            <p:txEl>
+                                              <p:pRg st="7" end="7"/>
+                                            </p:txEl>
+                                          </p:spTgt>
+                                        </p:tgtEl>
+                                        <p:attrNameLst>
+                                          <p:attrName>style.visibility</p:attrName>
+                                        </p:attrNameLst>
+                                      </p:cBhvr>
+                                      <p:to>
+                                        <p:strVal val="visible"/>
+                                      </p:to>
+                                    </p:set>
+                                    <p:animEffect transition="in" filter="fade">
+                                      <p:cBhvr>
+                                        <p:cTn id="42" dur="500"/>
+                                        <p:tgtEl>
+                                          <p:spTgt spid="90">
+                                            <p:txEl>
+                                              <p:pRg st="7" end="7"/>
+                                            </p:txEl>
+                                          </p:spTgt>
+                                        </p:tgtEl>
+                                      </p:cBhvr>
+                                    </p:animEffect>
+                                  </p:childTnLst>
+                                </p:cTn>
+                              </p:par>
+                            </p:childTnLst>
+                          </p:cTn>
+                        </p:par>
+                      </p:childTnLst>
+                    </p:cTn>
+                  </p:par>
+                </p:childTnLst>
+              </p:cTn>
+              <p:prevCondLst>
+                <p:cond evt="onPrev" delay="0">
+                  <p:tgtEl>
+                    <p:sldTgt/>
+                  </p:tgtEl>
+                </p:cond>
+              </p:prevCondLst>
+              <p:nextCondLst>
+                <p:cond evt="onNext" delay="0">
+                  <p:tgtEl>
+                    <p:sldTgt/>
+                  </p:tgtEl>
+                </p:cond>
+              </p:nextCondLst>
+            </p:seq>
+          </p:childTnLst>
+        </p:cTn>
+      </p:par>
+    </p:tnLst>
+    <p:bldLst>
+      <p:bldP spid="90" grpId="0" build="p"/>
+    </p:bldLst>
+  </p:timing>
+</p:sld>
+</file>
+
+<file path=ppt/slides/slide21.xml><?xml version="1.0" encoding="utf-8"?>
+<p:sld xmlns:a="http://schemas.openxmlformats.org/drawingml/2006/main" xmlns:r="http://schemas.openxmlformats.org/officeDocument/2006/relationships" xmlns:p="http://schemas.openxmlformats.org/presentationml/2006/main">
+  <p:cSld>
+    <p:spTree>
+      <p:nvGrpSpPr>
+        <p:cNvPr id="1" name=""/>
+        <p:cNvGrpSpPr/>
+        <p:nvPr/>
+      </p:nvGrpSpPr>
+      <p:grpSpPr>
+        <a:xfrm>
+          <a:off x="0" y="0"/>
+          <a:ext cx="0" cy="0"/>
+          <a:chOff x="0" y="0"/>
+          <a:chExt cx="0" cy="0"/>
+        </a:xfrm>
+      </p:grpSpPr>
+      <p:sp>
+        <p:nvSpPr>
+          <p:cNvPr id="5" name="TextBox 4">
+            <a:extLst>
+              <a:ext uri="{FF2B5EF4-FFF2-40B4-BE49-F238E27FC236}">
+                <a16:creationId xmlns:a16="http://schemas.microsoft.com/office/drawing/2014/main" id="{F13B2D6E-876F-C265-35AB-5F85CF521009}"/>
+              </a:ext>
+            </a:extLst>
+          </p:cNvPr>
+          <p:cNvSpPr txBox="1"/>
+          <p:nvPr/>
+        </p:nvSpPr>
+        <p:spPr>
+          <a:xfrm>
+            <a:off x="685800" y="360000"/>
+            <a:ext cx="7772400" cy="600000"/>
+          </a:xfrm>
+          <a:prstGeom prst="rect">
+            <a:avLst/>
+          </a:prstGeom>
+          <a:noFill/>
+        </p:spPr>
+        <p:txBody>
+          <a:bodyPr wrap="square">
+            <a:spAutoFit/>
+          </a:bodyPr>
+          <a:lstStyle/>
+          <a:p>
+            <a:pPr marL="0" lvl="0" indent="0" algn="ctr">
+              <a:lnSpc>
+                <a:spcPct val="115000"/>
+              </a:lnSpc>
+              <a:spcBef>
+                <a:spcPts val="600"/>
+              </a:spcBef>
+              <a:buSzPts val="1800"/>
+            </a:pPr>
+            <a:r>
+              <a:rPr lang="en-US" sz="1400" b="1" dirty="0"/>
+              <a:t>Questions?  |  </a:t>
+            </a:r>
+            <a:r>
+              <a:rPr lang="en-US" b="1" dirty="0"/>
+              <a:t>https://</a:t>
+            </a:r>
+            <a:r>
+              <a:rPr lang="en-US" b="1" dirty="0" err="1"/>
+              <a:t>github.com</a:t>
+            </a:r>
+            <a:r>
+              <a:rPr lang="en-US" b="1" dirty="0"/>
+              <a:t>/ram2valar/</a:t>
+            </a:r>
+            <a:r>
+              <a:rPr lang="en-US" b="1" dirty="0" err="1"/>
+              <a:t>kubeflow</a:t>
+            </a:r>
+            <a:r>
+              <a:rPr lang="en-US" b="1" dirty="0"/>
+              <a:t>-cilium-lab</a:t>
+            </a:r>
+            <a:endParaRPr lang="en-US" dirty="0"/>
+          </a:p>
+        </p:txBody>
+      </p:sp>
+      <p:pic>
+        <p:nvPicPr>
+          <p:cNvPr id="20" name="Ramkumar Nagaraj QR"/>
+          <p:cNvPicPr>
+            <a:picLocks noChangeAspect="1"/>
+          </p:cNvPicPr>
+          <p:nvPr/>
+        </p:nvPicPr>
+        <p:blipFill>
+          <a:blip r:embed="rId2"/>
+          <a:stretch>
+            <a:fillRect/>
+          </a:stretch>
+        </p:blipFill>
+        <p:spPr>
+          <a:xfrm>
+            <a:off x="1498900" y="1520000"/>
+            <a:ext cx="2657000" cy="2926080"/>
+          </a:xfrm>
+          <a:prstGeom prst="rect">
+            <a:avLst/>
+          </a:prstGeom>
+        </p:spPr>
+      </p:pic>
+      <p:pic>
+        <p:nvPicPr>
+          <p:cNvPr id="21" name="Bingi Narasimha Karthik QR"/>
+          <p:cNvPicPr>
+            <a:picLocks noChangeAspect="1"/>
+          </p:cNvPicPr>
+          <p:nvPr/>
+        </p:nvPicPr>
+        <p:blipFill>
+          <a:blip r:embed="rId3"/>
+          <a:stretch>
+            <a:fillRect/>
+          </a:stretch>
+        </p:blipFill>
+        <p:spPr>
+          <a:xfrm>
+            <a:off x="4613100" y="1520000"/>
+            <a:ext cx="3032000" cy="2926080"/>
+          </a:xfrm>
+          <a:prstGeom prst="rect">
+            <a:avLst/>
+          </a:prstGeom>
+        </p:spPr>
+      </p:pic>
+    </p:spTree>
+    <p:extLst>
+      <p:ext uri="{BB962C8B-B14F-4D97-AF65-F5344CB8AC3E}">
+        <p14:creationId xmlns:p14="http://schemas.microsoft.com/office/powerpoint/2010/main" val="1534186562"/>
+      </p:ext>
+    </p:extLst>
+  </p:cSld>
+  <p:clrMapOvr>
+    <a:masterClrMapping/>
+  </p:clrMapOvr>
+</p:sld>
+</file>
+
 <file path=ppt/slides/slide3.xml><?xml version="1.0" encoding="utf-8"?>
 <p:sld xmlns:a="http://schemas.openxmlformats.org/drawingml/2006/main" xmlns:r="http://schemas.openxmlformats.org/officeDocument/2006/relationships" xmlns:p="http://schemas.openxmlformats.org/presentationml/2006/main">
   <p:cSld>
@@ -14135,7 +14203,7 @@
         </p:nvSpPr>
         <p:spPr>
           <a:xfrm>
-            <a:off x="311700" y="1152475"/>
+            <a:off x="183812" y="1152475"/>
             <a:ext cx="3999900" cy="3317400"/>
           </a:xfrm>
           <a:prstGeom prst="rect">
@@ -14264,7 +14332,7 @@
               <a:rPr lang="en-US" sz="1800" b="1" dirty="0"/>
               <a:t>Cross-zone GPU traffic: DENY</a:t>
             </a:r>
-            <a:endParaRPr/>
+            <a:endParaRPr dirty="0"/>
           </a:p>
         </p:txBody>
       </p:sp>
@@ -14280,7 +14348,7 @@
         </p:nvSpPr>
         <p:spPr>
           <a:xfrm>
-            <a:off x="4832400" y="1152475"/>
+            <a:off x="5017838" y="1152475"/>
             <a:ext cx="3999900" cy="3317400"/>
           </a:xfrm>
           <a:prstGeom prst="rect">
@@ -14409,7 +14477,7 @@
               <a:rPr lang="en-US" sz="1800" b="0" dirty="0"/>
               <a:t>No GPU workers — coordinator ends up here</a:t>
             </a:r>
-            <a:endParaRPr/>
+            <a:endParaRPr dirty="0"/>
           </a:p>
         </p:txBody>
       </p:sp>
@@ -15216,7 +15284,7 @@
         </p:nvSpPr>
         <p:spPr>
           <a:xfrm>
-            <a:off x="311700" y="445025"/>
+            <a:off x="311700" y="227414"/>
             <a:ext cx="8520600" cy="572700"/>
           </a:xfrm>
           <a:prstGeom prst="rect">
@@ -15250,7 +15318,7 @@
               <a:rPr lang="en-US" sz="2800" b="1" dirty="0"/>
               <a:t>Default Kubeflow Scheduling: No Topology Awareness</a:t>
             </a:r>
-            <a:endParaRPr/>
+            <a:endParaRPr dirty="0"/>
           </a:p>
         </p:txBody>
       </p:sp>
@@ -15266,7 +15334,7 @@
         </p:nvSpPr>
         <p:spPr>
           <a:xfrm>
-            <a:off x="311700" y="1152475"/>
+            <a:off x="311700" y="1024588"/>
             <a:ext cx="8520600" cy="3317400"/>
           </a:xfrm>
           <a:prstGeom prst="rect">
@@ -15433,7 +15501,7 @@
               <a:rPr lang="en-US" sz="1800" b="0" dirty="0"/>
               <a:t>No kernel errors, no OOM — pods Running, training never starts</a:t>
             </a:r>
-            <a:endParaRPr/>
+            <a:endParaRPr dirty="0"/>
           </a:p>
         </p:txBody>
       </p:sp>
@@ -16005,8 +16073,8 @@
         </p:blipFill>
         <p:spPr>
           <a:xfrm>
-            <a:off x="195197" y="469127"/>
-            <a:ext cx="8598945" cy="3845986"/>
+            <a:off x="71131" y="89522"/>
+            <a:ext cx="9001738" cy="4380168"/>
           </a:xfrm>
           <a:prstGeom prst="rect">
             <a:avLst/>
@@ -16172,8 +16240,8 @@
         </p:blipFill>
         <p:spPr>
           <a:xfrm>
-            <a:off x="1526650" y="1424490"/>
-            <a:ext cx="6931550" cy="3353168"/>
+            <a:off x="1417945" y="1379728"/>
+            <a:ext cx="7661371" cy="3706222"/>
           </a:xfrm>
           <a:prstGeom prst="rect">
             <a:avLst/>
@@ -16329,7 +16397,7 @@
         </p:nvSpPr>
         <p:spPr>
           <a:xfrm>
-            <a:off x="311700" y="445025"/>
+            <a:off x="311700" y="99443"/>
             <a:ext cx="8520600" cy="572700"/>
           </a:xfrm>
           <a:prstGeom prst="rect">
@@ -16363,7 +16431,7 @@
               <a:rPr lang="en-US" sz="2800" b="1" dirty="0"/>
               <a:t>Cilium’s Topology-Aware Network Policy</a:t>
             </a:r>
-            <a:endParaRPr/>
+            <a:endParaRPr dirty="0"/>
           </a:p>
         </p:txBody>
       </p:sp>
@@ -16379,7 +16447,7 @@
         </p:nvSpPr>
         <p:spPr>
           <a:xfrm>
-            <a:off x="311700" y="1152475"/>
+            <a:off x="311700" y="868289"/>
             <a:ext cx="3999900" cy="3317400"/>
           </a:xfrm>
           <a:prstGeom prst="rect">
@@ -16508,7 +16576,7 @@
               <a:rPr lang="en-US" sz="1800" b="1" dirty="0"/>
               <a:t>the scheduler didn’t know about it</a:t>
             </a:r>
-            <a:endParaRPr/>
+            <a:endParaRPr dirty="0"/>
           </a:p>
         </p:txBody>
       </p:sp>
@@ -16524,7 +16592,7 @@
         </p:nvSpPr>
         <p:spPr>
           <a:xfrm>
-            <a:off x="4832400" y="1152475"/>
+            <a:off x="4979471" y="1256267"/>
             <a:ext cx="3999900" cy="3317400"/>
           </a:xfrm>
           <a:prstGeom prst="rect">
@@ -16710,7 +16778,7 @@
               <a:rPr lang="en-US" sz="1600" b="1" dirty="0"/>
               <a:t>      matchLabels: {zone: zone-b}</a:t>
             </a:r>
-            <a:endParaRPr/>
+            <a:endParaRPr dirty="0"/>
           </a:p>
         </p:txBody>
       </p:sp>

</xml_diff>